<commit_message>
[ FEAT ]: Agregar lámina de registro Entra y URI de api-cloud-native
Co-authored-by: Cursor <cursoragent@cursor.com>
</commit_message>
<xml_diff>
--- a/entregables/MesaTech_EV1_Presentacion.pptx
+++ b/entregables/MesaTech_EV1_Presentacion.pptx
@@ -10,6 +10,7 @@
     <p:sldId id="258" r:id="rId10"/>
     <p:sldId id="259" r:id="rId11"/>
     <p:sldId id="260" r:id="rId12"/>
+    <p:sldId id="273" r:id="rId25"/>
     <p:sldId id="261" r:id="rId13"/>
     <p:sldId id="262" r:id="rId14"/>
     <p:sldId id="263" r:id="rId15"/>
@@ -1277,6 +1278,98 @@
           <a:p>
             <a:r>
               <a:t>No abrir la app ahora. El MVP no es un ITSM completo; cumple el flujo mínimo de la EP1. Después de «Preguntas», cállense y esperen. Si nadie pregunta, no rellenen.</a:t>
+            </a:r>
+          </a:p>
+        </p:txBody>
+      </p:sp>
+      <p:sp>
+        <p:nvSpPr>
+          <p:cNvPr id="4" name="Slide Number Placeholder 3"/>
+          <p:cNvSpPr>
+            <a:spLocks noGrp="1"/>
+          </p:cNvSpPr>
+          <p:nvPr>
+            <p:ph type="sldNum" idx="5" sz="quarter"/>
+          </p:nvPr>
+        </p:nvSpPr>
+        <p:spPr/>
+      </p:sp>
+    </p:spTree>
+  </p:cSld>
+  <p:clrMapOvr>
+    <a:masterClrMapping/>
+  </p:clrMapOvr>
+</p:notes>
+</file>
+
+<file path=ppt/notesSlides/notesSlide18.xml><?xml version="1.0" encoding="utf-8"?>
+<p:notes xmlns:a="http://schemas.openxmlformats.org/drawingml/2006/main" xmlns:p="http://schemas.openxmlformats.org/presentationml/2006/main">
+  <p:cSld>
+    <p:spTree>
+      <p:nvGrpSpPr>
+        <p:cNvPr id="1" name=""/>
+        <p:cNvGrpSpPr/>
+        <p:nvPr/>
+      </p:nvGrpSpPr>
+      <p:grpSpPr>
+        <a:xfrm>
+          <a:off x="0" y="0"/>
+          <a:ext cx="0" cy="0"/>
+          <a:chOff x="0" y="0"/>
+          <a:chExt cx="0" cy="0"/>
+        </a:xfrm>
+      </p:grpSpPr>
+      <p:sp>
+        <p:nvSpPr>
+          <p:cNvPr id="2" name="Slide Image Placeholder 1"/>
+          <p:cNvSpPr>
+            <a:spLocks noGrp="1"/>
+          </p:cNvSpPr>
+          <p:nvPr>
+            <p:ph type="sldImg" idx="2"/>
+          </p:nvPr>
+        </p:nvSpPr>
+        <p:spPr/>
+      </p:sp>
+      <p:sp>
+        <p:nvSpPr>
+          <p:cNvPr id="3" name="Notes Placeholder 2"/>
+          <p:cNvSpPr>
+            <a:spLocks noGrp="1"/>
+          </p:cNvSpPr>
+          <p:nvPr>
+            <p:ph type="body" idx="3" sz="quarter"/>
+          </p:nvPr>
+        </p:nvSpPr>
+        <p:spPr/>
+        <p:txBody>
+          <a:bodyPr/>
+          <a:lstStyle/>
+          <a:p>
+            <a:r>
+              <a:t>HABLA · Ari · 35 s</a:t>
+            </a:r>
+          </a:p>
+          <a:p/>
+          <a:p>
+            <a:r>
+              <a:t>DECIR</a:t>
+            </a:r>
+          </a:p>
+          <a:p>
+            <a:r>
+              <a:t>El primer paso de identidad fue registrar la API. En Entra ID se creó una aplicación nueva, no la SPA: se llama api-cloud-native. En la captura de la izquierda está el formulario: un solo inquilino, y sin URI de redirección, porque esta app no es el login del navegador. A la derecha se creó el URI de id. de aplicación: api:// más el Id. de aplicación. Ese URI es el prefijo de los scopes. El consentimiento y los roles vienen en la lámina siguiente.</a:t>
+            </a:r>
+          </a:p>
+          <a:p/>
+          <a:p>
+            <a:r>
+              <a:t>SI PREGUNTAN</a:t>
+            </a:r>
+          </a:p>
+          <a:p>
+            <a:r>
+              <a:t>No leas los UUID. Redirect URI vacío a propósito: vive en la SPA. El URI se acepta el que propone Azure. Evidencia: Word de Ari, Parte A, Registro de Aplicación y Creación de URI de id de Apps. Si preguntan por el audience: es el Id. de aplicación de esta API, no el de React.</a:t>
             </a:r>
           </a:p>
         </p:txBody>
@@ -11129,6 +11222,595 @@
                 <a:latin typeface="Calibri"/>
               </a:rPr>
               <a:t>Docente   Paulo Andrés Berríos Díaz</a:t>
+            </a:r>
+          </a:p>
+        </p:txBody>
+      </p:sp>
+    </p:spTree>
+  </p:cSld>
+  <p:clrMapOvr>
+    <a:masterClrMapping/>
+  </p:clrMapOvr>
+</p:sld>
+</file>
+
+<file path=ppt/slides/slide18.xml><?xml version="1.0" encoding="utf-8"?>
+<p:sld xmlns:a="http://schemas.openxmlformats.org/drawingml/2006/main" xmlns:p="http://schemas.openxmlformats.org/presentationml/2006/main" xmlns:r="http://schemas.openxmlformats.org/officeDocument/2006/relationships">
+  <p:cSld>
+    <p:spTree>
+      <p:nvGrpSpPr>
+        <p:cNvPr id="1" name=""/>
+        <p:cNvGrpSpPr/>
+        <p:nvPr/>
+      </p:nvGrpSpPr>
+      <p:grpSpPr/>
+      <p:sp>
+        <p:nvSpPr>
+          <p:cNvPr id="2" name="Rectangle 1"/>
+          <p:cNvSpPr/>
+          <p:nvPr/>
+        </p:nvSpPr>
+        <p:spPr>
+          <a:xfrm>
+            <a:off x="0" y="0"/>
+            <a:ext cx="12191695" cy="6858000"/>
+          </a:xfrm>
+          <a:prstGeom prst="rect">
+            <a:avLst/>
+          </a:prstGeom>
+          <a:solidFill>
+            <a:srgbClr val="F7FBFA"/>
+          </a:solidFill>
+          <a:ln>
+            <a:noFill/>
+          </a:ln>
+        </p:spPr>
+        <p:style>
+          <a:lnRef idx="1">
+            <a:schemeClr val="accent1"/>
+          </a:lnRef>
+          <a:fillRef idx="3">
+            <a:schemeClr val="accent1"/>
+          </a:fillRef>
+          <a:effectRef idx="2">
+            <a:schemeClr val="accent1"/>
+          </a:effectRef>
+          <a:fontRef idx="minor">
+            <a:schemeClr val="lt1"/>
+          </a:fontRef>
+        </p:style>
+        <p:txBody>
+          <a:bodyPr rtlCol="0" anchor="ctr"/>
+          <a:lstStyle/>
+          <a:p>
+            <a:pPr algn="ctr"/>
+          </a:p>
+        </p:txBody>
+      </p:sp>
+      <p:sp>
+        <p:nvSpPr>
+          <p:cNvPr id="3" name="Rectangle 2"/>
+          <p:cNvSpPr/>
+          <p:nvPr/>
+        </p:nvSpPr>
+        <p:spPr>
+          <a:xfrm>
+            <a:off x="0" y="0"/>
+            <a:ext cx="12191695" cy="566928"/>
+          </a:xfrm>
+          <a:prstGeom prst="rect">
+            <a:avLst/>
+          </a:prstGeom>
+          <a:solidFill>
+            <a:srgbClr val="FFFFFF"/>
+          </a:solidFill>
+          <a:ln>
+            <a:noFill/>
+          </a:ln>
+        </p:spPr>
+        <p:style>
+          <a:lnRef idx="1">
+            <a:schemeClr val="accent1"/>
+          </a:lnRef>
+          <a:fillRef idx="3">
+            <a:schemeClr val="accent1"/>
+          </a:fillRef>
+          <a:effectRef idx="2">
+            <a:schemeClr val="accent1"/>
+          </a:effectRef>
+          <a:fontRef idx="minor">
+            <a:schemeClr val="lt1"/>
+          </a:fontRef>
+        </p:style>
+        <p:txBody>
+          <a:bodyPr rtlCol="0" anchor="ctr"/>
+          <a:lstStyle/>
+          <a:p>
+            <a:pPr algn="ctr"/>
+          </a:p>
+        </p:txBody>
+      </p:sp>
+      <p:sp>
+        <p:nvSpPr>
+          <p:cNvPr id="4" name="Rectangle 3"/>
+          <p:cNvSpPr/>
+          <p:nvPr/>
+        </p:nvSpPr>
+        <p:spPr>
+          <a:xfrm>
+            <a:off x="0" y="566928"/>
+            <a:ext cx="12191695" cy="54864"/>
+          </a:xfrm>
+          <a:prstGeom prst="rect">
+            <a:avLst/>
+          </a:prstGeom>
+          <a:solidFill>
+            <a:srgbClr val="2EC4B6"/>
+          </a:solidFill>
+          <a:ln>
+            <a:noFill/>
+          </a:ln>
+        </p:spPr>
+        <p:style>
+          <a:lnRef idx="1">
+            <a:schemeClr val="accent1"/>
+          </a:lnRef>
+          <a:fillRef idx="3">
+            <a:schemeClr val="accent1"/>
+          </a:fillRef>
+          <a:effectRef idx="2">
+            <a:schemeClr val="accent1"/>
+          </a:effectRef>
+          <a:fontRef idx="minor">
+            <a:schemeClr val="lt1"/>
+          </a:fontRef>
+        </p:style>
+        <p:txBody>
+          <a:bodyPr rtlCol="0" anchor="ctr"/>
+          <a:lstStyle/>
+          <a:p>
+            <a:pPr algn="ctr"/>
+          </a:p>
+        </p:txBody>
+      </p:sp>
+      <p:pic>
+        <p:nvPicPr>
+          <p:cNvPr id="5" name="Picture 4" descr="logo.png"/>
+          <p:cNvPicPr>
+            <a:picLocks noChangeAspect="1"/>
+          </p:cNvPicPr>
+          <p:nvPr/>
+        </p:nvPicPr>
+        <p:blipFill>
+          <a:blip r:embed="rId2"/>
+          <a:stretch>
+            <a:fillRect/>
+          </a:stretch>
+        </p:blipFill>
+        <p:spPr>
+          <a:xfrm>
+            <a:off x="384048" y="91440"/>
+            <a:ext cx="365760" cy="365760"/>
+          </a:xfrm>
+          <a:prstGeom prst="rect">
+            <a:avLst/>
+          </a:prstGeom>
+        </p:spPr>
+      </p:pic>
+      <p:sp>
+        <p:nvSpPr>
+          <p:cNvPr id="6" name="TextBox 5"/>
+          <p:cNvSpPr txBox="1"/>
+          <p:nvPr/>
+        </p:nvSpPr>
+        <p:spPr>
+          <a:xfrm>
+            <a:off x="868680" y="109728"/>
+            <a:ext cx="5486400" cy="365760"/>
+          </a:xfrm>
+          <a:prstGeom prst="rect">
+            <a:avLst/>
+          </a:prstGeom>
+          <a:noFill/>
+        </p:spPr>
+        <p:txBody>
+          <a:bodyPr wrap="square" anchor="t"/>
+          <a:lstStyle/>
+          <a:p>
+            <a:pPr algn="r"/>
+            <a:r>
+              <a:rPr sz="1300" b="1">
+                <a:solidFill>
+                  <a:srgbClr val="0F4C5C"/>
+                </a:solidFill>
+                <a:latin typeface="Calibri"/>
+              </a:rPr>
+              <a:t>MESATECH  CLOUD</a:t>
+            </a:r>
+          </a:p>
+        </p:txBody>
+      </p:sp>
+      <p:sp>
+        <p:nvSpPr>
+          <p:cNvPr id="7" name="TextBox 6"/>
+          <p:cNvSpPr txBox="1"/>
+          <p:nvPr/>
+        </p:nvSpPr>
+        <p:spPr>
+          <a:xfrm>
+            <a:off x="7863840" y="109728"/>
+            <a:ext cx="3931920" cy="365760"/>
+          </a:xfrm>
+          <a:prstGeom prst="rect">
+            <a:avLst/>
+          </a:prstGeom>
+          <a:noFill/>
+        </p:spPr>
+        <p:txBody>
+          <a:bodyPr wrap="square" anchor="ctr"/>
+          <a:lstStyle/>
+          <a:p>
+            <a:pPr algn="r"/>
+            <a:r>
+              <a:rPr sz="1200" b="1">
+                <a:solidFill>
+                  <a:srgbClr val="4A646C"/>
+                </a:solidFill>
+                <a:latin typeface="Calibri"/>
+              </a:rPr>
+              <a:t>03 · Registro   ·   Ari</a:t>
+            </a:r>
+          </a:p>
+        </p:txBody>
+      </p:sp>
+      <p:sp>
+        <p:nvSpPr>
+          <p:cNvPr id="8" name="TextBox 7"/>
+          <p:cNvSpPr txBox="1"/>
+          <p:nvPr/>
+        </p:nvSpPr>
+        <p:spPr>
+          <a:xfrm>
+            <a:off x="365760" y="731520"/>
+            <a:ext cx="11430000" cy="237744"/>
+          </a:xfrm>
+          <a:prstGeom prst="rect">
+            <a:avLst/>
+          </a:prstGeom>
+          <a:noFill/>
+        </p:spPr>
+        <p:txBody>
+          <a:bodyPr wrap="square" anchor="t"/>
+          <a:lstStyle/>
+          <a:p>
+            <a:pPr algn="l"/>
+            <a:r>
+              <a:rPr sz="1100" b="1">
+                <a:solidFill>
+                  <a:srgbClr val="2EC4B6"/>
+                </a:solidFill>
+                <a:latin typeface="Calibri"/>
+              </a:rPr>
+              <a:t>MICROSOFT ENTRA ID</a:t>
+            </a:r>
+          </a:p>
+        </p:txBody>
+      </p:sp>
+      <p:sp>
+        <p:nvSpPr>
+          <p:cNvPr id="9" name="TextBox 8"/>
+          <p:cNvSpPr txBox="1"/>
+          <p:nvPr/>
+        </p:nvSpPr>
+        <p:spPr>
+          <a:xfrm>
+            <a:off x="365760" y="960120"/>
+            <a:ext cx="11430000" cy="777240"/>
+          </a:xfrm>
+          <a:prstGeom prst="rect">
+            <a:avLst/>
+          </a:prstGeom>
+          <a:noFill/>
+        </p:spPr>
+        <p:txBody>
+          <a:bodyPr wrap="square" anchor="t"/>
+          <a:lstStyle/>
+          <a:p>
+            <a:pPr algn="l"/>
+            <a:r>
+              <a:rPr sz="2600" b="1">
+                <a:solidFill>
+                  <a:srgbClr val="0A3843"/>
+                </a:solidFill>
+                <a:latin typeface="Calibri"/>
+              </a:rPr>
+              <a:t>Registrar api-cloud-native. Crear el URI.</a:t>
+            </a:r>
+          </a:p>
+        </p:txBody>
+      </p:sp>
+      <p:sp>
+        <p:nvSpPr>
+          <p:cNvPr id="10" name="Rounded Rectangle 9"/>
+          <p:cNvSpPr/>
+          <p:nvPr/>
+        </p:nvSpPr>
+        <p:spPr>
+          <a:xfrm>
+            <a:off x="365760" y="1965960"/>
+            <a:ext cx="5349240" cy="3794760"/>
+          </a:xfrm>
+          <a:prstGeom prst="roundRect">
+            <a:avLst/>
+          </a:prstGeom>
+          <a:solidFill>
+            <a:srgbClr val="FFFFFF"/>
+          </a:solidFill>
+          <a:ln>
+            <a:noFill/>
+          </a:ln>
+        </p:spPr>
+        <p:style>
+          <a:lnRef idx="1">
+            <a:schemeClr val="accent1"/>
+          </a:lnRef>
+          <a:fillRef idx="3">
+            <a:schemeClr val="accent1"/>
+          </a:fillRef>
+          <a:effectRef idx="2">
+            <a:schemeClr val="accent1"/>
+          </a:effectRef>
+          <a:fontRef idx="minor">
+            <a:schemeClr val="lt1"/>
+          </a:fontRef>
+        </p:style>
+        <p:txBody>
+          <a:bodyPr rtlCol="0" anchor="ctr"/>
+          <a:lstStyle/>
+          <a:p>
+            <a:pPr algn="ctr"/>
+          </a:p>
+        </p:txBody>
+      </p:sp>
+      <p:sp>
+        <p:nvSpPr>
+          <p:cNvPr id="11" name="Rounded Rectangle 10"/>
+          <p:cNvSpPr/>
+          <p:nvPr/>
+        </p:nvSpPr>
+        <p:spPr>
+          <a:xfrm>
+            <a:off x="6473952" y="1965960"/>
+            <a:ext cx="5349240" cy="3794760"/>
+          </a:xfrm>
+          <a:prstGeom prst="roundRect">
+            <a:avLst/>
+          </a:prstGeom>
+          <a:solidFill>
+            <a:srgbClr val="FFFFFF"/>
+          </a:solidFill>
+          <a:ln>
+            <a:noFill/>
+          </a:ln>
+        </p:spPr>
+        <p:style>
+          <a:lnRef idx="1">
+            <a:schemeClr val="accent1"/>
+          </a:lnRef>
+          <a:fillRef idx="3">
+            <a:schemeClr val="accent1"/>
+          </a:fillRef>
+          <a:effectRef idx="2">
+            <a:schemeClr val="accent1"/>
+          </a:effectRef>
+          <a:fontRef idx="minor">
+            <a:schemeClr val="lt1"/>
+          </a:fontRef>
+        </p:style>
+        <p:txBody>
+          <a:bodyPr rtlCol="0" anchor="ctr"/>
+          <a:lstStyle/>
+          <a:p>
+            <a:pPr algn="ctr"/>
+          </a:p>
+        </p:txBody>
+      </p:sp>
+      <p:pic>
+        <p:nvPicPr>
+          <p:cNvPr id="12" name="Picture 11" descr="ari-consent.png"/>
+          <p:cNvPicPr>
+            <a:picLocks noChangeAspect="1"/>
+          </p:cNvPicPr>
+          <p:nvPr/>
+        </p:nvPicPr>
+        <p:blipFill>
+          <a:blip r:embed="rId3"/>
+          <a:stretch>
+            <a:fillRect/>
+          </a:stretch>
+        </p:blipFill>
+        <p:spPr>
+          <a:xfrm>
+            <a:off x="502920" y="2400860"/>
+            <a:ext cx="5074920" cy="2522621"/>
+          </a:xfrm>
+          <a:prstGeom prst="rect">
+            <a:avLst/>
+          </a:prstGeom>
+        </p:spPr>
+      </p:pic>
+      <p:pic>
+        <p:nvPicPr>
+          <p:cNvPr id="13" name="Picture 12" descr="ari-roles.png"/>
+          <p:cNvPicPr>
+            <a:picLocks noChangeAspect="1"/>
+          </p:cNvPicPr>
+          <p:nvPr/>
+        </p:nvPicPr>
+        <p:blipFill>
+          <a:blip r:embed="rId4"/>
+          <a:stretch>
+            <a:fillRect/>
+          </a:stretch>
+        </p:blipFill>
+        <p:spPr>
+          <a:xfrm>
+            <a:off x="6611112" y="2452796"/>
+            <a:ext cx="5074920" cy="2418748"/>
+          </a:xfrm>
+          <a:prstGeom prst="rect">
+            <a:avLst/>
+          </a:prstGeom>
+        </p:spPr>
+      </p:pic>
+      <p:sp>
+        <p:nvSpPr>
+          <p:cNvPr id="14" name="Rectangle 13"/>
+          <p:cNvSpPr/>
+          <p:nvPr/>
+        </p:nvSpPr>
+        <p:spPr>
+          <a:xfrm>
+            <a:off x="365760" y="6291072"/>
+            <a:ext cx="73152" cy="310896"/>
+          </a:xfrm>
+          <a:prstGeom prst="rect">
+            <a:avLst/>
+          </a:prstGeom>
+          <a:solidFill>
+            <a:srgbClr val="2EC4B6"/>
+          </a:solidFill>
+          <a:ln>
+            <a:noFill/>
+          </a:ln>
+        </p:spPr>
+        <p:style>
+          <a:lnRef idx="1">
+            <a:schemeClr val="accent1"/>
+          </a:lnRef>
+          <a:fillRef idx="3">
+            <a:schemeClr val="accent1"/>
+          </a:fillRef>
+          <a:effectRef idx="2">
+            <a:schemeClr val="accent1"/>
+          </a:effectRef>
+          <a:fontRef idx="minor">
+            <a:schemeClr val="lt1"/>
+          </a:fontRef>
+        </p:style>
+        <p:txBody>
+          <a:bodyPr rtlCol="0" anchor="ctr"/>
+          <a:lstStyle/>
+          <a:p>
+            <a:pPr algn="ctr"/>
+          </a:p>
+        </p:txBody>
+      </p:sp>
+      <p:sp>
+        <p:nvSpPr>
+          <p:cNvPr id="15" name="TextBox 14"/>
+          <p:cNvSpPr txBox="1"/>
+          <p:nvPr/>
+        </p:nvSpPr>
+        <p:spPr>
+          <a:xfrm>
+            <a:off x="512064" y="6291072"/>
+            <a:ext cx="5202936" cy="384048"/>
+          </a:xfrm>
+          <a:prstGeom prst="rect">
+            <a:avLst/>
+          </a:prstGeom>
+          <a:noFill/>
+        </p:spPr>
+        <p:txBody>
+          <a:bodyPr wrap="square" anchor="t"/>
+          <a:lstStyle/>
+          <a:p>
+            <a:pPr algn="l"/>
+            <a:r>
+              <a:rPr sz="1100" b="0">
+                <a:solidFill>
+                  <a:srgbClr val="4A646C"/>
+                </a:solidFill>
+                <a:latin typeface="Calibri"/>
+              </a:rPr>
+              <a:t>Formulario de registro. Nombre api-cloud-native. Un solo inquilino. Sin URI de redirección.</a:t>
+            </a:r>
+          </a:p>
+        </p:txBody>
+      </p:sp>
+      <p:sp>
+        <p:nvSpPr>
+          <p:cNvPr id="16" name="Rectangle 15"/>
+          <p:cNvSpPr/>
+          <p:nvPr/>
+        </p:nvSpPr>
+        <p:spPr>
+          <a:xfrm>
+            <a:off x="6473952" y="6291072"/>
+            <a:ext cx="73152" cy="310896"/>
+          </a:xfrm>
+          <a:prstGeom prst="rect">
+            <a:avLst/>
+          </a:prstGeom>
+          <a:solidFill>
+            <a:srgbClr val="2EC4B6"/>
+          </a:solidFill>
+          <a:ln>
+            <a:noFill/>
+          </a:ln>
+        </p:spPr>
+        <p:style>
+          <a:lnRef idx="1">
+            <a:schemeClr val="accent1"/>
+          </a:lnRef>
+          <a:fillRef idx="3">
+            <a:schemeClr val="accent1"/>
+          </a:fillRef>
+          <a:effectRef idx="2">
+            <a:schemeClr val="accent1"/>
+          </a:effectRef>
+          <a:fontRef idx="minor">
+            <a:schemeClr val="lt1"/>
+          </a:fontRef>
+        </p:style>
+        <p:txBody>
+          <a:bodyPr rtlCol="0" anchor="ctr"/>
+          <a:lstStyle/>
+          <a:p>
+            <a:pPr algn="ctr"/>
+          </a:p>
+        </p:txBody>
+      </p:sp>
+      <p:sp>
+        <p:nvSpPr>
+          <p:cNvPr id="17" name="TextBox 16"/>
+          <p:cNvSpPr txBox="1"/>
+          <p:nvPr/>
+        </p:nvSpPr>
+        <p:spPr>
+          <a:xfrm>
+            <a:off x="6620256" y="6291072"/>
+            <a:ext cx="5202936" cy="384048"/>
+          </a:xfrm>
+          <a:prstGeom prst="rect">
+            <a:avLst/>
+          </a:prstGeom>
+          <a:noFill/>
+        </p:spPr>
+        <p:txBody>
+          <a:bodyPr wrap="square" anchor="t"/>
+          <a:lstStyle/>
+          <a:p>
+            <a:pPr algn="l"/>
+            <a:r>
+              <a:rPr sz="1100" b="0">
+                <a:solidFill>
+                  <a:srgbClr val="4A646C"/>
+                </a:solidFill>
+                <a:latin typeface="Calibri"/>
+              </a:rPr>
+              <a:t>URI de id. de aplicación: api:// más el Id. de aplicación. Prefijo de los scopes.</a:t>
             </a:r>
           </a:p>
         </p:txBody>

</xml_diff>